<commit_message>
Add authors and abstract affiliations to title slide
</commit_message>
<xml_diff>
--- a/docs/presentation/cohort-pnc-2026.pptx
+++ b/docs/presentation/cohort-pnc-2026.pptx
@@ -553,7 +553,7 @@
           </a:p>
           <a:p>
             <a:r>
-              <a:t>Opening. Introduce yourself and your affiliation verbally. This is a presentation of working research tools, with a bounded example, not a claim to solve translator ascription.</a:t>
+              <a:t>Opening. Authors: Shu-Kai Hsieh, Da-Chen Lian, Chunki Lim and Lang-Ching Yeh. All are affiliated with the Graduate Institute of Linguistics, National Taiwan University. Shu-Kai Hsieh and Da-Chen Lian also list the Humanistic-AI lab, College of Liberal Arts, National Taiwan University. Affiliations follow the supplied abstract; name spellings follow the presenter’s correction. This is a presentation of working research tools, with a bounded example, not a claim to solve translator ascription.</a:t>
             </a:r>
           </a:p>
           <a:p/>
@@ -7548,42 +7548,138 @@
         </p:nvSpPr>
         <p:spPr>
           <a:xfrm>
-            <a:off x="552450" y="5410200"/>
-            <a:ext cx="10477500" cy="428625"/>
-          </a:xfrm>
-          <a:prstGeom prst="rect">
-            <a:avLst/>
-          </a:prstGeom>
-          <a:noFill/>
-        </p:spPr>
-        <p:txBody>
-          <a:bodyPr wrap="square" lIns="0" rIns="0" tIns="0" bIns="0">
-            <a:spAutoFit/>
-          </a:bodyPr>
-          <a:lstStyle/>
-          <a:p>
-            <a:pPr>
-              <a:lnSpc>
-                <a:spcPct val="118000"/>
-              </a:lnSpc>
-              <a:spcBef>
-                <a:spcPts val="0"/>
-              </a:spcBef>
-              <a:spcAft>
-                <a:spcPts val="0"/>
-              </a:spcAft>
-              <a:defRPr sz="2100" b="0">
-                <a:solidFill>
-                  <a:srgbClr val="526778"/>
-                </a:solidFill>
-                <a:latin typeface="Lato"/>
-              </a:defRPr>
-            </a:pPr>
-            <a:r>
-              <a:rPr>
-                <a:ea typeface="Microsoft JhengHei"/>
-              </a:rPr>
-              <a:t>Chinese Buddhist texts · researcher-controlled investigation</a:t>
+            <a:off x="552450" y="5124450"/>
+            <a:ext cx="11049000" cy="333375"/>
+          </a:xfrm>
+          <a:prstGeom prst="rect">
+            <a:avLst/>
+          </a:prstGeom>
+          <a:noFill/>
+        </p:spPr>
+        <p:txBody>
+          <a:bodyPr wrap="square" lIns="0" rIns="0" tIns="0" bIns="0">
+            <a:spAutoFit/>
+          </a:bodyPr>
+          <a:lstStyle/>
+          <a:p>
+            <a:pPr>
+              <a:lnSpc>
+                <a:spcPct val="118000"/>
+              </a:lnSpc>
+              <a:spcBef>
+                <a:spcPts val="0"/>
+              </a:spcBef>
+              <a:spcAft>
+                <a:spcPts val="0"/>
+              </a:spcAft>
+              <a:defRPr sz="2300" b="0">
+                <a:solidFill>
+                  <a:srgbClr val="24384A"/>
+                </a:solidFill>
+                <a:latin typeface="Lato"/>
+              </a:defRPr>
+            </a:pPr>
+            <a:r>
+              <a:rPr>
+                <a:ea typeface="Microsoft JhengHei"/>
+              </a:rPr>
+              <a:t>Shu-Kai Hsieh¹² · Da-Chen Lian¹² · Chunki Lim¹ · Lang-Ching Yeh¹</a:t>
+            </a:r>
+          </a:p>
+        </p:txBody>
+      </p:sp>
+      <p:sp>
+        <p:nvSpPr>
+          <p:cNvPr id="9" name="TextBox 8"/>
+          <p:cNvSpPr txBox="1"/>
+          <p:nvPr/>
+        </p:nvSpPr>
+        <p:spPr>
+          <a:xfrm>
+            <a:off x="552450" y="5600700"/>
+            <a:ext cx="11049000" cy="333375"/>
+          </a:xfrm>
+          <a:prstGeom prst="rect">
+            <a:avLst/>
+          </a:prstGeom>
+          <a:noFill/>
+        </p:spPr>
+        <p:txBody>
+          <a:bodyPr wrap="square" lIns="0" rIns="0" tIns="0" bIns="0">
+            <a:spAutoFit/>
+          </a:bodyPr>
+          <a:lstStyle/>
+          <a:p>
+            <a:pPr>
+              <a:lnSpc>
+                <a:spcPct val="118000"/>
+              </a:lnSpc>
+              <a:spcBef>
+                <a:spcPts val="0"/>
+              </a:spcBef>
+              <a:spcAft>
+                <a:spcPts val="0"/>
+              </a:spcAft>
+              <a:defRPr sz="1700" b="0">
+                <a:solidFill>
+                  <a:srgbClr val="24384A"/>
+                </a:solidFill>
+                <a:latin typeface="Lato"/>
+              </a:defRPr>
+            </a:pPr>
+            <a:r>
+              <a:rPr>
+                <a:ea typeface="Microsoft JhengHei"/>
+              </a:rPr>
+              <a:t>¹ Graduate Institute of Linguistics, National Taiwan University, Taipei, Taiwan</a:t>
+            </a:r>
+          </a:p>
+        </p:txBody>
+      </p:sp>
+      <p:sp>
+        <p:nvSpPr>
+          <p:cNvPr id="10" name="TextBox 9"/>
+          <p:cNvSpPr txBox="1"/>
+          <p:nvPr/>
+        </p:nvSpPr>
+        <p:spPr>
+          <a:xfrm>
+            <a:off x="552450" y="5876925"/>
+            <a:ext cx="11049000" cy="333375"/>
+          </a:xfrm>
+          <a:prstGeom prst="rect">
+            <a:avLst/>
+          </a:prstGeom>
+          <a:noFill/>
+        </p:spPr>
+        <p:txBody>
+          <a:bodyPr wrap="square" lIns="0" rIns="0" tIns="0" bIns="0">
+            <a:spAutoFit/>
+          </a:bodyPr>
+          <a:lstStyle/>
+          <a:p>
+            <a:pPr>
+              <a:lnSpc>
+                <a:spcPct val="118000"/>
+              </a:lnSpc>
+              <a:spcBef>
+                <a:spcPts val="0"/>
+              </a:spcBef>
+              <a:spcAft>
+                <a:spcPts val="0"/>
+              </a:spcAft>
+              <a:defRPr sz="1700" b="0">
+                <a:solidFill>
+                  <a:srgbClr val="24384A"/>
+                </a:solidFill>
+                <a:latin typeface="Lato"/>
+              </a:defRPr>
+            </a:pPr>
+            <a:r>
+              <a:rPr>
+                <a:ea typeface="Microsoft JhengHei"/>
+              </a:rPr>
+              <a:t>² Humanistic-AI lab, College of Liberal Arts, National Taiwan University, Taipei, Taiwan</a:t>
             </a:r>
           </a:p>
         </p:txBody>

</xml_diff>

<commit_message>
Explain agent proposals, research follow-ups and grounding limits
</commit_message>
<xml_diff>
--- a/docs/presentation/cohort-pnc-2026.pptx
+++ b/docs/presentation/cohort-pnc-2026.pptx
@@ -1376,178 +1376,34 @@
           <a:lstStyle/>
           <a:p>
             <a:r>
-              <a:t>SAY: The worker chooses tools and proposes. The reviewer records checks. The analyst explains a selected view and can investigate further, but cannot write graph proposals.</a:t>
+              <a:t>SAY: The worker can pull material together, suggest explanations we might want to examine, and propose a next search. These are possibilities for research. We inspect the cited passages and recorded checks before deciding what to pursue.</a:t>
             </a:r>
           </a:p>
           <a:p/>
           <a:p>
             <a:r>
-              <a:t>BACKGROUND</a:t>
-            </a:r>
-          </a:p>
-          <a:p>
-            <a:r>
-              <a:t>## Technical reference: what runs in each tab</a:t>
+              <a:t>EXAMPLE: When a commentary shares wording with an earlier text, the worker could suggest reuse, a common source or a recurring formula. A useful next step is to search other texts for the same wording, or repeat the vocabulary comparison with the commentary excluded. These are examples of questions an agent can propose, not a claim that the saved run discovered a new historical relationship.</a:t>
             </a:r>
           </a:p>
           <a:p/>
           <a:p>
             <a:r>
-              <a:t>| Tab | What runs | What it saves |</a:t>
-            </a:r>
-          </a:p>
-          <a:p>
-            <a:r>
-              <a:t>|---|---|---|</a:t>
-            </a:r>
-          </a:p>
-          <a:p>
-            <a:r>
-              <a:t>| Corpus | Exact phrase search reads the local corpus. Related passages compares stored embedding vectors. Shared-wording checks locate matching character sequences. | Browsing alone adds nothing to the evidence graph. Investigate this passage fills an Inquiry draft. |</a:t>
-            </a:r>
-          </a:p>
-          <a:p>
-            <a:r>
-              <a:t>| Vocabulary comparison | Counts strings in the target and scores it against catalogue-labelled group profiles. The target’s whole work is withheld; you can exclude other works. | Calculations alone add no graph nodes. The ranking changes with the vocabulary and reference material. |</a:t>
-            </a:r>
-          </a:p>
-          <a:p>
-            <a:r>
-              <a:t>| Inquiry | A language-model worker chooses tools and proposes claims or conjectures. A separate reviewer uses a different model family to check proposals. | The question, recorded proposals, citations, checks and run activity. Reopen completed runs under Run results. |</a:t>
-            </a:r>
-          </a:p>
-          <a:p>
-            <a:r>
-              <a:t>| Findings | Reads the saved claims and conjectures, their cited passages and recorded checks. | It displays the existing investigation; opening the tab does not run another worker. |</a:t>
-            </a:r>
-          </a:p>
-          <a:p>
-            <a:r>
-              <a:t>| Graph | Draws saved records and their relationships. Show exploration adds recorded tool activity. | Accepting or rejecting an eligible record saves a researcher decision. Hiding nodes only changes the view. |</a:t>
+              <a:t>GROUNDING: The Graph stores links between passages and proposals, source locations, author/model records, checks and researcher decisions. It lets us inspect the basis of a proposal. It does not make an interpretation true. A reviewer can verify that a quotation occurs while still making a mistaken judgement about what it supports.</a:t>
             </a:r>
           </a:p>
           <a:p/>
           <a:p>
             <a:r>
-              <a:t>Graph and Vocabulary comparison also have an AI analyst. It can use read-only tools and continue a conversation about the selected view. Its explanation does not automatically become a graph proposal.</a:t>
+              <a:t>ROLES: The Inquiry worker calls tools and records proposals. A reviewer from a different model family records checks. The separate analyst in Graph and Vocabulary comparison can explain outputs and make further read-only tool calls; its response does not automatically become a graph proposal.</a:t>
             </a:r>
           </a:p>
           <a:p/>
           <a:p>
             <a:r>
-              <a:t>### The embedder and the worker are different models</a:t>
+              <a:t>DIAGRAM: This is a high-level workflow, not the Graph's edge vocabulary or a promise that every retrieved passage is saved. The researcher chooses what to pursue; opening a tab does not execute this sequence.</a:t>
             </a:r>
           </a:p>
           <a:p/>
-          <a:p>
-            <a:r>
-              <a:t>The configured embedding file is `mitra-qwen35-embedder.npz`. It holds vectors computed before the session. Corpus → Related passages compares the selected passage’s vector with other stored vectors using cosine similarity. Higher scores mean closer vectors; read the returned passages to decide whether the relationship is useful.</a:t>
-            </a:r>
-          </a:p>
-          <a:p/>
-          <a:p>
-            <a:r>
-              <a:t>Inquiry workers and the view analyst can search these embeddings with `semantic_neighbors`. They use them only if they call that tool. Exact phrase search, string-frequency rankings, citation checks and graph drawing do not use the embedder.</a:t>
-            </a:r>
-          </a:p>
-          <a:p/>
-          <a:p>
-            <a:r>
-              <a:t>The filename identifies the embedder as `mitra-qwen35-embedder`. The legacy index does not record its exact model revision. Its coverage and training limitations are described under Semantic analysis and alignment below. The worker and reviewer model names are shown separately in Inquiry and in saved run records.</a:t>
-            </a:r>
-          </a:p>
-          <a:p/>
-          <a:p/>
-          <a:p>
-            <a:r>
-              <a:t>The index has no recorded model revision. Do not claim that the example texts were absent from training.</a:t>
-            </a:r>
-          </a:p>
-          <a:p/>
-          <a:p>
-            <a:r>
-              <a:t>Open Analyze this view without starting a run. Show a saved analysis if one is available. The analyst can use read-only tools, but does not promote its answer into a graph proposal.</a:t>
-            </a:r>
-          </a:p>
-          <a:p/>
-          <a:p>
-            <a:r>
-              <a:t>Click **Analyze this view**. A side panel opens without moving the main tab. Choose or retain the model, then click **Start analysis**. Merely opening the panel does not call a model.</a:t>
-            </a:r>
-          </a:p>
-          <a:p/>
-          <a:p>
-            <a:r>
-              <a:t>The analyst can inspect records, search passages, read bounded source material and repeat available evidence comparisons. Its final answer is formatted text with expandable actions and reasons. It cannot propose, accept, reject or modify graph records. Its explanation is an AI interpretation, not a verification.</a:t>
-            </a:r>
-          </a:p>
-          <a:p/>
-          <a:p>
-            <a:r>
-              <a:t>Select an entry under **Saved analyses** to reopen it. The answer describes the view supplied when that analysis began; later changes to the graph or exclusion settings do not rewrite it. Close the panel to inspect the underlying view. Closing or switching tabs does not stop an active run. Only one inquiry or analysis runs at a time in this instance.</a:t>
-            </a:r>
-          </a:p>
-          <a:p/>
-          <a:p>
-            <a:r>
-              <a:t>Do not click Accept just to create an ending. Show available controls and explain their actual eligibility rules. The reviewer cannot be treated as a reliable semantic validator; explain the current limitation if asked.</a:t>
-            </a:r>
-          </a:p>
-          <a:p/>
-          <a:p>
-            <a:r>
-              <a:t>| Status | Meaning |</a:t>
-            </a:r>
-          </a:p>
-          <a:p>
-            <a:r>
-              <a:t>|---|---|</a:t>
-            </a:r>
-          </a:p>
-          <a:p>
-            <a:r>
-              <a:t>| Proposed | Submitted for consideration |</a:t>
-            </a:r>
-          </a:p>
-          <a:p>
-            <a:r>
-              <a:t>| Attested | The required promotion checks for that record type passed |</a:t>
-            </a:r>
-          </a:p>
-          <a:p>
-            <a:r>
-              <a:t>| Accepted | The researcher approved this record under Cohort’s citation rules |</a:t>
-            </a:r>
-          </a:p>
-          <a:p>
-            <a:r>
-              <a:t>| Rejected | The researcher rejected this record with a reason |</a:t>
-            </a:r>
-          </a:p>
-          <a:p/>
-          <a:p>
-            <a:r>
-              <a:t>A **contradiction** relationship is distinct from a researcher’s rejection. Colour alone is insufficient: some imported experiment records also have calculated assessment colours. Read the selected record’s status.</a:t>
-            </a:r>
-          </a:p>
-          <a:p/>
-          <a:p>
-            <a:r>
-              <a:t>An eligible attested record can be accepted. Accepting a passage changes that passage’s status; it does not accept every connected claim. Rejecting a record preserves it and the reason rather than deleting a source text. Reopening a rejected record also requires a reason.</a:t>
-            </a:r>
-          </a:p>
-          <a:p/>
-          <a:p>
-            <a:r>
-              <a:t>The reviewer is fallible. In the current implementation, its tool re-fetches cited passages and checks their spans, but the reviewer does not have a complete evidence-reading workflow before choosing its semantic verdict. A reviewer’s statement that it checked an interpretation or reproduced a calculation is not enough to establish that it did so. The researcher should inspect the passages and numerical output directly. This limitation remains open; do not say it has been repaired by changing model names.</a:t>
-            </a:r>
-          </a:p>
-          <a:p/>
-          <a:p>
-            <a:r>
-              <a:t>The Vocabulary comparison tab does not currently offer a grounded `quotes` or `parallel_of` edge proposal for later acceptance. Accepting a graph record also does not change Vocabulary comparison profiles. The exclusion above is a separate researcher-controlled calculation.</a:t>
-            </a:r>
-          </a:p>
         </p:txBody>
       </p:sp>
       <p:sp>
@@ -9353,7 +9209,7 @@
               <a:rPr>
                 <a:ea typeface="Microsoft JhengHei"/>
               </a:rPr>
-              <a:t>Agent roles</a:t>
+              <a:t>Interpretation · agents and researcher</a:t>
             </a:r>
           </a:p>
         </p:txBody>
@@ -9367,7 +9223,7 @@
         <p:spPr>
           <a:xfrm>
             <a:off x="495299" y="742950"/>
-            <a:ext cx="11144250" cy="1047749"/>
+            <a:ext cx="11144250" cy="952500"/>
           </a:xfrm>
           <a:prstGeom prst="rect">
             <a:avLst/>
@@ -9401,7 +9257,7 @@
               <a:rPr>
                 <a:ea typeface="Microsoft JhengHei"/>
               </a:rPr>
-              <a:t>Worker, reviewer and analyst</a:t>
+              <a:t>From passages to research proposals</a:t>
             </a:r>
           </a:p>
         </p:txBody>
@@ -9414,79 +9270,31 @@
         </p:nvSpPr>
         <p:spPr>
           <a:xfrm>
-            <a:off x="714375" y="2247900"/>
-            <a:ext cx="2952750" cy="476250"/>
-          </a:xfrm>
-          <a:prstGeom prst="rect">
-            <a:avLst/>
-          </a:prstGeom>
-          <a:noFill/>
-        </p:spPr>
-        <p:txBody>
-          <a:bodyPr wrap="square" lIns="0" rIns="0" tIns="0" bIns="0">
-            <a:spAutoFit/>
-          </a:bodyPr>
-          <a:lstStyle/>
-          <a:p>
-            <a:pPr>
-              <a:lnSpc>
-                <a:spcPct val="118000"/>
-              </a:lnSpc>
-              <a:spcBef>
-                <a:spcPts val="0"/>
-              </a:spcBef>
-              <a:spcAft>
-                <a:spcPts val="0"/>
-              </a:spcAft>
-              <a:defRPr sz="2300" b="1">
-                <a:solidFill>
-                  <a:srgbClr val="65439A"/>
-                </a:solidFill>
-                <a:latin typeface="Lato"/>
-              </a:defRPr>
-            </a:pPr>
-            <a:r>
-              <a:rPr>
-                <a:ea typeface="Microsoft JhengHei"/>
-              </a:rPr>
-              <a:t>Worker</a:t>
-            </a:r>
-          </a:p>
-        </p:txBody>
-      </p:sp>
-      <p:sp>
-        <p:nvSpPr>
-          <p:cNvPr id="5" name="TextBox 4"/>
-          <p:cNvSpPr txBox="1"/>
-          <p:nvPr/>
-        </p:nvSpPr>
-        <p:spPr>
-          <a:xfrm>
-            <a:off x="714375" y="2857500"/>
-            <a:ext cx="2952750" cy="1762125"/>
-          </a:xfrm>
-          <a:prstGeom prst="rect">
-            <a:avLst/>
-          </a:prstGeom>
-          <a:noFill/>
-        </p:spPr>
-        <p:txBody>
-          <a:bodyPr wrap="square" lIns="0" rIns="0" tIns="0" bIns="0">
-            <a:spAutoFit/>
-          </a:bodyPr>
-          <a:lstStyle/>
-          <a:p>
-            <a:pPr>
-              <a:lnSpc>
-                <a:spcPct val="118000"/>
-              </a:lnSpc>
-              <a:spcBef>
-                <a:spcPts val="0"/>
-              </a:spcBef>
-              <a:spcAft>
-                <a:spcPts val="0"/>
-              </a:spcAft>
-              <a:defRPr sz="2100" b="0">
+            <a:off x="523874" y="1828800"/>
+            <a:ext cx="11049000" cy="781050"/>
+          </a:xfrm>
+          <a:prstGeom prst="rect">
+            <a:avLst/>
+          </a:prstGeom>
+          <a:noFill/>
+        </p:spPr>
+        <p:txBody>
+          <a:bodyPr wrap="square" lIns="0" rIns="0" tIns="0" bIns="0">
+            <a:spAutoFit/>
+          </a:bodyPr>
+          <a:lstStyle/>
+          <a:p>
+            <a:pPr>
+              <a:lnSpc>
+                <a:spcPct val="118000"/>
+              </a:lnSpc>
+              <a:spcBef>
+                <a:spcPts val="0"/>
+              </a:spcBef>
+              <a:spcAft>
+                <a:spcPts val="0"/>
+              </a:spcAft>
+              <a:defRPr sz="2600" b="0">
                 <a:solidFill>
                   <a:srgbClr val="24384A"/>
                 </a:solidFill>
@@ -9497,478 +9305,31 @@
               <a:rPr>
                 <a:ea typeface="Microsoft JhengHei"/>
               </a:rPr>
-              <a:t>Search and compare</a:t>
-            </a:r>
-          </a:p>
-          <a:p>
-            <a:pPr>
-              <a:lnSpc>
-                <a:spcPct val="118000"/>
-              </a:lnSpc>
-              <a:spcBef>
-                <a:spcPts val="0"/>
-              </a:spcBef>
-              <a:spcAft>
-                <a:spcPts val="0"/>
-              </a:spcAft>
-              <a:defRPr sz="2100" b="0">
-                <a:solidFill>
-                  <a:srgbClr val="24384A"/>
-                </a:solidFill>
-                <a:latin typeface="Lato"/>
-              </a:defRPr>
-            </a:pPr>
-          </a:p>
-          <a:p>
-            <a:pPr>
-              <a:lnSpc>
-                <a:spcPct val="118000"/>
-              </a:lnSpc>
-              <a:spcBef>
-                <a:spcPts val="0"/>
-              </a:spcBef>
-              <a:spcAft>
-                <a:spcPts val="0"/>
-              </a:spcAft>
-              <a:defRPr sz="2100" b="0">
-                <a:solidFill>
-                  <a:srgbClr val="24384A"/>
-                </a:solidFill>
-                <a:latin typeface="Lato"/>
-              </a:defRPr>
-            </a:pPr>
-            <a:r>
-              <a:rPr>
-                <a:ea typeface="Microsoft JhengHei"/>
-              </a:rPr>
-              <a:t>Record proposals</a:t>
-            </a:r>
-          </a:p>
-          <a:p>
-            <a:pPr>
-              <a:lnSpc>
-                <a:spcPct val="118000"/>
-              </a:lnSpc>
-              <a:spcBef>
-                <a:spcPts val="0"/>
-              </a:spcBef>
-              <a:spcAft>
-                <a:spcPts val="0"/>
-              </a:spcAft>
-              <a:defRPr sz="2100" b="0">
-                <a:solidFill>
-                  <a:srgbClr val="24384A"/>
-                </a:solidFill>
-                <a:latin typeface="Lato"/>
-              </a:defRPr>
-            </a:pPr>
-            <a:r>
-              <a:rPr>
-                <a:ea typeface="Microsoft JhengHei"/>
-              </a:rPr>
-              <a:t>and citations</a:t>
-            </a:r>
-          </a:p>
-        </p:txBody>
-      </p:sp>
-      <p:sp>
-        <p:nvSpPr>
-          <p:cNvPr id="6" name="TextBox 5"/>
-          <p:cNvSpPr txBox="1"/>
-          <p:nvPr/>
-        </p:nvSpPr>
-        <p:spPr>
-          <a:xfrm>
-            <a:off x="4619625" y="2247900"/>
-            <a:ext cx="2952750" cy="476250"/>
-          </a:xfrm>
-          <a:prstGeom prst="rect">
-            <a:avLst/>
-          </a:prstGeom>
-          <a:noFill/>
-        </p:spPr>
-        <p:txBody>
-          <a:bodyPr wrap="square" lIns="0" rIns="0" tIns="0" bIns="0">
-            <a:spAutoFit/>
-          </a:bodyPr>
-          <a:lstStyle/>
-          <a:p>
-            <a:pPr>
-              <a:lnSpc>
-                <a:spcPct val="118000"/>
-              </a:lnSpc>
-              <a:spcBef>
-                <a:spcPts val="0"/>
-              </a:spcBef>
-              <a:spcAft>
-                <a:spcPts val="0"/>
-              </a:spcAft>
-              <a:defRPr sz="2300" b="1">
-                <a:solidFill>
-                  <a:srgbClr val="146C68"/>
-                </a:solidFill>
-                <a:latin typeface="Lato"/>
-              </a:defRPr>
-            </a:pPr>
-            <a:r>
-              <a:rPr>
-                <a:ea typeface="Microsoft JhengHei"/>
-              </a:rPr>
-              <a:t>Reviewer</a:t>
-            </a:r>
-          </a:p>
-        </p:txBody>
-      </p:sp>
-      <p:sp>
-        <p:nvSpPr>
-          <p:cNvPr id="7" name="TextBox 6"/>
-          <p:cNvSpPr txBox="1"/>
-          <p:nvPr/>
-        </p:nvSpPr>
-        <p:spPr>
-          <a:xfrm>
-            <a:off x="4619625" y="2857500"/>
-            <a:ext cx="2952750" cy="1762125"/>
-          </a:xfrm>
-          <a:prstGeom prst="rect">
-            <a:avLst/>
-          </a:prstGeom>
-          <a:noFill/>
-        </p:spPr>
-        <p:txBody>
-          <a:bodyPr wrap="square" lIns="0" rIns="0" tIns="0" bIns="0">
-            <a:spAutoFit/>
-          </a:bodyPr>
-          <a:lstStyle/>
-          <a:p>
-            <a:pPr>
-              <a:lnSpc>
-                <a:spcPct val="118000"/>
-              </a:lnSpc>
-              <a:spcBef>
-                <a:spcPts val="0"/>
-              </a:spcBef>
-              <a:spcAft>
-                <a:spcPts val="0"/>
-              </a:spcAft>
-              <a:defRPr sz="2100" b="0">
-                <a:solidFill>
-                  <a:srgbClr val="24384A"/>
-                </a:solidFill>
-                <a:latin typeface="Lato"/>
-              </a:defRPr>
-            </a:pPr>
-            <a:r>
-              <a:rPr>
-                <a:ea typeface="Microsoft JhengHei"/>
-              </a:rPr>
-              <a:t>Different model family</a:t>
-            </a:r>
-          </a:p>
-          <a:p>
-            <a:pPr>
-              <a:lnSpc>
-                <a:spcPct val="118000"/>
-              </a:lnSpc>
-              <a:spcBef>
-                <a:spcPts val="0"/>
-              </a:spcBef>
-              <a:spcAft>
-                <a:spcPts val="0"/>
-              </a:spcAft>
-              <a:defRPr sz="2100" b="0">
-                <a:solidFill>
-                  <a:srgbClr val="24384A"/>
-                </a:solidFill>
-                <a:latin typeface="Lato"/>
-              </a:defRPr>
-            </a:pPr>
-          </a:p>
-          <a:p>
-            <a:pPr>
-              <a:lnSpc>
-                <a:spcPct val="118000"/>
-              </a:lnSpc>
-              <a:spcBef>
-                <a:spcPts val="0"/>
-              </a:spcBef>
-              <a:spcAft>
-                <a:spcPts val="0"/>
-              </a:spcAft>
-              <a:defRPr sz="2100" b="0">
-                <a:solidFill>
-                  <a:srgbClr val="24384A"/>
-                </a:solidFill>
-                <a:latin typeface="Lato"/>
-              </a:defRPr>
-            </a:pPr>
-            <a:r>
-              <a:rPr>
-                <a:ea typeface="Microsoft JhengHei"/>
-              </a:rPr>
-              <a:t>Record citation checks</a:t>
-            </a:r>
-          </a:p>
-          <a:p>
-            <a:pPr>
-              <a:lnSpc>
-                <a:spcPct val="118000"/>
-              </a:lnSpc>
-              <a:spcBef>
-                <a:spcPts val="0"/>
-              </a:spcBef>
-              <a:spcAft>
-                <a:spcPts val="0"/>
-              </a:spcAft>
-              <a:defRPr sz="2100" b="0">
-                <a:solidFill>
-                  <a:srgbClr val="24384A"/>
-                </a:solidFill>
-                <a:latin typeface="Lato"/>
-              </a:defRPr>
-            </a:pPr>
-            <a:r>
-              <a:rPr>
-                <a:ea typeface="Microsoft JhengHei"/>
-              </a:rPr>
-              <a:t>and review verdicts</a:t>
-            </a:r>
-          </a:p>
-        </p:txBody>
-      </p:sp>
-      <p:sp>
-        <p:nvSpPr>
-          <p:cNvPr id="8" name="TextBox 7"/>
-          <p:cNvSpPr txBox="1"/>
-          <p:nvPr/>
-        </p:nvSpPr>
-        <p:spPr>
-          <a:xfrm>
-            <a:off x="8524875" y="2247900"/>
-            <a:ext cx="2952750" cy="476250"/>
-          </a:xfrm>
-          <a:prstGeom prst="rect">
-            <a:avLst/>
-          </a:prstGeom>
-          <a:noFill/>
-        </p:spPr>
-        <p:txBody>
-          <a:bodyPr wrap="square" lIns="0" rIns="0" tIns="0" bIns="0">
-            <a:spAutoFit/>
-          </a:bodyPr>
-          <a:lstStyle/>
-          <a:p>
-            <a:pPr>
-              <a:lnSpc>
-                <a:spcPct val="118000"/>
-              </a:lnSpc>
-              <a:spcBef>
-                <a:spcPts val="0"/>
-              </a:spcBef>
-              <a:spcAft>
-                <a:spcPts val="0"/>
-              </a:spcAft>
-              <a:defRPr sz="2300" b="1">
-                <a:solidFill>
-                  <a:srgbClr val="155F88"/>
-                </a:solidFill>
-                <a:latin typeface="Lato"/>
-              </a:defRPr>
-            </a:pPr>
-            <a:r>
-              <a:rPr>
-                <a:ea typeface="Microsoft JhengHei"/>
-              </a:rPr>
-              <a:t>View analyst</a:t>
-            </a:r>
-          </a:p>
-        </p:txBody>
-      </p:sp>
-      <p:sp>
-        <p:nvSpPr>
-          <p:cNvPr id="9" name="TextBox 8"/>
-          <p:cNvSpPr txBox="1"/>
-          <p:nvPr/>
-        </p:nvSpPr>
-        <p:spPr>
-          <a:xfrm>
-            <a:off x="8524875" y="2857500"/>
-            <a:ext cx="2952750" cy="1762125"/>
-          </a:xfrm>
-          <a:prstGeom prst="rect">
-            <a:avLst/>
-          </a:prstGeom>
-          <a:noFill/>
-        </p:spPr>
-        <p:txBody>
-          <a:bodyPr wrap="square" lIns="0" rIns="0" tIns="0" bIns="0">
-            <a:spAutoFit/>
-          </a:bodyPr>
-          <a:lstStyle/>
-          <a:p>
-            <a:pPr>
-              <a:lnSpc>
-                <a:spcPct val="118000"/>
-              </a:lnSpc>
-              <a:spcBef>
-                <a:spcPts val="0"/>
-              </a:spcBef>
-              <a:spcAft>
-                <a:spcPts val="0"/>
-              </a:spcAft>
-              <a:defRPr sz="2100" b="0">
-                <a:solidFill>
-                  <a:srgbClr val="24384A"/>
-                </a:solidFill>
-                <a:latin typeface="Lato"/>
-              </a:defRPr>
-            </a:pPr>
-            <a:r>
-              <a:rPr>
-                <a:ea typeface="Microsoft JhengHei"/>
-              </a:rPr>
-              <a:t>Graph and vocabulary</a:t>
-            </a:r>
-          </a:p>
-          <a:p>
-            <a:pPr>
-              <a:lnSpc>
-                <a:spcPct val="118000"/>
-              </a:lnSpc>
-              <a:spcBef>
-                <a:spcPts val="0"/>
-              </a:spcBef>
-              <a:spcAft>
-                <a:spcPts val="0"/>
-              </a:spcAft>
-              <a:defRPr sz="2100" b="0">
-                <a:solidFill>
-                  <a:srgbClr val="24384A"/>
-                </a:solidFill>
-                <a:latin typeface="Lato"/>
-              </a:defRPr>
-            </a:pPr>
-          </a:p>
-          <a:p>
-            <a:pPr>
-              <a:lnSpc>
-                <a:spcPct val="118000"/>
-              </a:lnSpc>
-              <a:spcBef>
-                <a:spcPts val="0"/>
-              </a:spcBef>
-              <a:spcAft>
-                <a:spcPts val="0"/>
-              </a:spcAft>
-              <a:defRPr sz="2100" b="0">
-                <a:solidFill>
-                  <a:srgbClr val="24384A"/>
-                </a:solidFill>
-                <a:latin typeface="Lato"/>
-              </a:defRPr>
-            </a:pPr>
-            <a:r>
-              <a:rPr>
-                <a:ea typeface="Microsoft JhengHei"/>
-              </a:rPr>
-              <a:t>Explain outputs; use</a:t>
-            </a:r>
-          </a:p>
-          <a:p>
-            <a:pPr>
-              <a:lnSpc>
-                <a:spcPct val="118000"/>
-              </a:lnSpc>
-              <a:spcBef>
-                <a:spcPts val="0"/>
-              </a:spcBef>
-              <a:spcAft>
-                <a:spcPts val="0"/>
-              </a:spcAft>
-              <a:defRPr sz="2100" b="0">
-                <a:solidFill>
-                  <a:srgbClr val="24384A"/>
-                </a:solidFill>
-                <a:latin typeface="Lato"/>
-              </a:defRPr>
-            </a:pPr>
-            <a:r>
-              <a:rPr>
-                <a:ea typeface="Microsoft JhengHei"/>
-              </a:rPr>
-              <a:t>read-only tools</a:t>
-            </a:r>
-          </a:p>
-        </p:txBody>
-      </p:sp>
-      <p:sp>
-        <p:nvSpPr>
-          <p:cNvPr id="10" name="TextBox 9"/>
-          <p:cNvSpPr txBox="1"/>
-          <p:nvPr/>
-        </p:nvSpPr>
-        <p:spPr>
-          <a:xfrm>
-            <a:off x="523874" y="5324475"/>
-            <a:ext cx="11049000" cy="762000"/>
-          </a:xfrm>
-          <a:prstGeom prst="rect">
-            <a:avLst/>
-          </a:prstGeom>
-          <a:noFill/>
-        </p:spPr>
-        <p:txBody>
-          <a:bodyPr wrap="square" lIns="0" rIns="0" tIns="0" bIns="0">
-            <a:spAutoFit/>
-          </a:bodyPr>
-          <a:lstStyle/>
-          <a:p>
-            <a:pPr>
-              <a:lnSpc>
-                <a:spcPct val="118000"/>
-              </a:lnSpc>
-              <a:spcBef>
-                <a:spcPts val="0"/>
-              </a:spcBef>
-              <a:spcAft>
-                <a:spcPts val="0"/>
-              </a:spcAft>
-              <a:defRPr sz="2500" b="0">
-                <a:solidFill>
-                  <a:srgbClr val="24384A"/>
-                </a:solidFill>
-                <a:latin typeface="Lato"/>
-              </a:defRPr>
-            </a:pPr>
-            <a:r>
-              <a:rPr>
-                <a:ea typeface="Microsoft JhengHei"/>
-              </a:rPr>
-              <a:t>Model names and actions are recorded. A reviewer can still be wrong.</a:t>
-            </a:r>
-          </a:p>
-        </p:txBody>
-      </p:sp>
-      <p:sp>
-        <p:nvSpPr>
-          <p:cNvPr id="11" name="Rectangle 10"/>
+              <a:t>Agents can compare material, suggest explanations and propose follow-up searches.</a:t>
+            </a:r>
+          </a:p>
+        </p:txBody>
+      </p:sp>
+      <p:sp>
+        <p:nvSpPr>
+          <p:cNvPr id="5" name="Rectangle 4"/>
           <p:cNvSpPr/>
           <p:nvPr/>
         </p:nvSpPr>
         <p:spPr>
           <a:xfrm>
-            <a:off x="11334750" y="6429375"/>
-            <a:ext cx="647700" cy="333375"/>
+            <a:off x="523874" y="3048000"/>
+            <a:ext cx="3333750" cy="1666875"/>
           </a:xfrm>
           <a:prstGeom prst="rect">
             <a:avLst/>
           </a:prstGeom>
           <a:solidFill>
-            <a:srgbClr val="24384A"/>
+            <a:srgbClr val="E8F3FA"/>
           </a:solidFill>
           <a:ln w="12700">
             <a:solidFill>
-              <a:srgbClr val="24384A"/>
+              <a:srgbClr val="155F88"/>
             </a:solidFill>
           </a:ln>
         </p:spPr>
@@ -9996,7 +9357,721 @@
       </p:sp>
       <p:sp>
         <p:nvSpPr>
+          <p:cNvPr id="6" name="TextBox 5"/>
+          <p:cNvSpPr txBox="1"/>
+          <p:nvPr/>
+        </p:nvSpPr>
+        <p:spPr>
+          <a:xfrm>
+            <a:off x="695325" y="3219450"/>
+            <a:ext cx="2990850" cy="476250"/>
+          </a:xfrm>
+          <a:prstGeom prst="rect">
+            <a:avLst/>
+          </a:prstGeom>
+          <a:noFill/>
+        </p:spPr>
+        <p:txBody>
+          <a:bodyPr wrap="square" lIns="0" rIns="0" tIns="0" bIns="0">
+            <a:spAutoFit/>
+          </a:bodyPr>
+          <a:lstStyle/>
+          <a:p>
+            <a:pPr>
+              <a:lnSpc>
+                <a:spcPct val="118000"/>
+              </a:lnSpc>
+              <a:spcBef>
+                <a:spcPts val="0"/>
+              </a:spcBef>
+              <a:spcAft>
+                <a:spcPts val="0"/>
+              </a:spcAft>
+              <a:defRPr sz="2200" b="1">
+                <a:solidFill>
+                  <a:srgbClr val="155F88"/>
+                </a:solidFill>
+                <a:latin typeface="Lato"/>
+              </a:defRPr>
+            </a:pPr>
+            <a:r>
+              <a:rPr>
+                <a:ea typeface="Microsoft JhengHei"/>
+              </a:rPr>
+              <a:t>Read and compare</a:t>
+            </a:r>
+          </a:p>
+        </p:txBody>
+      </p:sp>
+      <p:sp>
+        <p:nvSpPr>
+          <p:cNvPr id="7" name="TextBox 6"/>
+          <p:cNvSpPr txBox="1"/>
+          <p:nvPr/>
+        </p:nvSpPr>
+        <p:spPr>
+          <a:xfrm>
+            <a:off x="695325" y="3857625"/>
+            <a:ext cx="2990850" cy="742950"/>
+          </a:xfrm>
+          <a:prstGeom prst="rect">
+            <a:avLst/>
+          </a:prstGeom>
+          <a:noFill/>
+        </p:spPr>
+        <p:txBody>
+          <a:bodyPr wrap="square" lIns="0" rIns="0" tIns="0" bIns="0">
+            <a:spAutoFit/>
+          </a:bodyPr>
+          <a:lstStyle/>
+          <a:p>
+            <a:pPr>
+              <a:lnSpc>
+                <a:spcPct val="118000"/>
+              </a:lnSpc>
+              <a:spcBef>
+                <a:spcPts val="0"/>
+              </a:spcBef>
+              <a:spcAft>
+                <a:spcPts val="0"/>
+              </a:spcAft>
+              <a:defRPr sz="2000" b="0">
+                <a:solidFill>
+                  <a:srgbClr val="24384A"/>
+                </a:solidFill>
+                <a:latin typeface="Lato"/>
+              </a:defRPr>
+            </a:pPr>
+            <a:r>
+              <a:rPr>
+                <a:ea typeface="Microsoft JhengHei"/>
+              </a:rPr>
+              <a:t>Retrieve passages</a:t>
+            </a:r>
+          </a:p>
+          <a:p>
+            <a:pPr>
+              <a:lnSpc>
+                <a:spcPct val="118000"/>
+              </a:lnSpc>
+              <a:spcBef>
+                <a:spcPts val="0"/>
+              </a:spcBef>
+              <a:spcAft>
+                <a:spcPts val="0"/>
+              </a:spcAft>
+              <a:defRPr sz="2000" b="0">
+                <a:solidFill>
+                  <a:srgbClr val="24384A"/>
+                </a:solidFill>
+                <a:latin typeface="Lato"/>
+              </a:defRPr>
+            </a:pPr>
+            <a:r>
+              <a:rPr>
+                <a:ea typeface="Microsoft JhengHei"/>
+              </a:rPr>
+              <a:t>Summarise observations</a:t>
+            </a:r>
+          </a:p>
+        </p:txBody>
+      </p:sp>
+      <p:sp>
+        <p:nvSpPr>
+          <p:cNvPr id="8" name="Rectangle 7"/>
+          <p:cNvSpPr/>
+          <p:nvPr/>
+        </p:nvSpPr>
+        <p:spPr>
+          <a:xfrm>
+            <a:off x="4429125" y="3048000"/>
+            <a:ext cx="3333750" cy="1666875"/>
+          </a:xfrm>
+          <a:prstGeom prst="rect">
+            <a:avLst/>
+          </a:prstGeom>
+          <a:solidFill>
+            <a:srgbClr val="F0EBF8"/>
+          </a:solidFill>
+          <a:ln w="12700">
+            <a:solidFill>
+              <a:srgbClr val="65439A"/>
+            </a:solidFill>
+          </a:ln>
+        </p:spPr>
+        <p:style>
+          <a:lnRef idx="1">
+            <a:schemeClr val="accent1"/>
+          </a:lnRef>
+          <a:fillRef idx="3">
+            <a:schemeClr val="accent1"/>
+          </a:fillRef>
+          <a:effectRef idx="2">
+            <a:schemeClr val="accent1"/>
+          </a:effectRef>
+          <a:fontRef idx="minor">
+            <a:schemeClr val="lt1"/>
+          </a:fontRef>
+        </p:style>
+        <p:txBody>
+          <a:bodyPr rtlCol="0" anchor="ctr"/>
+          <a:lstStyle/>
+          <a:p>
+            <a:pPr algn="ctr"/>
+          </a:p>
+        </p:txBody>
+      </p:sp>
+      <p:sp>
+        <p:nvSpPr>
+          <p:cNvPr id="9" name="TextBox 8"/>
+          <p:cNvSpPr txBox="1"/>
+          <p:nvPr/>
+        </p:nvSpPr>
+        <p:spPr>
+          <a:xfrm>
+            <a:off x="4600575" y="3219450"/>
+            <a:ext cx="2990850" cy="476250"/>
+          </a:xfrm>
+          <a:prstGeom prst="rect">
+            <a:avLst/>
+          </a:prstGeom>
+          <a:noFill/>
+        </p:spPr>
+        <p:txBody>
+          <a:bodyPr wrap="square" lIns="0" rIns="0" tIns="0" bIns="0">
+            <a:spAutoFit/>
+          </a:bodyPr>
+          <a:lstStyle/>
+          <a:p>
+            <a:pPr>
+              <a:lnSpc>
+                <a:spcPct val="118000"/>
+              </a:lnSpc>
+              <a:spcBef>
+                <a:spcPts val="0"/>
+              </a:spcBef>
+              <a:spcAft>
+                <a:spcPts val="0"/>
+              </a:spcAft>
+              <a:defRPr sz="2200" b="1">
+                <a:solidFill>
+                  <a:srgbClr val="65439A"/>
+                </a:solidFill>
+                <a:latin typeface="Lato"/>
+              </a:defRPr>
+            </a:pPr>
+            <a:r>
+              <a:rPr>
+                <a:ea typeface="Microsoft JhengHei"/>
+              </a:rPr>
+              <a:t>Propose</a:t>
+            </a:r>
+          </a:p>
+        </p:txBody>
+      </p:sp>
+      <p:sp>
+        <p:nvSpPr>
+          <p:cNvPr id="10" name="TextBox 9"/>
+          <p:cNvSpPr txBox="1"/>
+          <p:nvPr/>
+        </p:nvSpPr>
+        <p:spPr>
+          <a:xfrm>
+            <a:off x="4600575" y="3857625"/>
+            <a:ext cx="2990850" cy="742950"/>
+          </a:xfrm>
+          <a:prstGeom prst="rect">
+            <a:avLst/>
+          </a:prstGeom>
+          <a:noFill/>
+        </p:spPr>
+        <p:txBody>
+          <a:bodyPr wrap="square" lIns="0" rIns="0" tIns="0" bIns="0">
+            <a:spAutoFit/>
+          </a:bodyPr>
+          <a:lstStyle/>
+          <a:p>
+            <a:pPr>
+              <a:lnSpc>
+                <a:spcPct val="118000"/>
+              </a:lnSpc>
+              <a:spcBef>
+                <a:spcPts val="0"/>
+              </a:spcBef>
+              <a:spcAft>
+                <a:spcPts val="0"/>
+              </a:spcAft>
+              <a:defRPr sz="2000" b="0">
+                <a:solidFill>
+                  <a:srgbClr val="24384A"/>
+                </a:solidFill>
+                <a:latin typeface="Lato"/>
+              </a:defRPr>
+            </a:pPr>
+            <a:r>
+              <a:rPr>
+                <a:ea typeface="Microsoft JhengHei"/>
+              </a:rPr>
+              <a:t>Possible explanations</a:t>
+            </a:r>
+          </a:p>
+          <a:p>
+            <a:pPr>
+              <a:lnSpc>
+                <a:spcPct val="118000"/>
+              </a:lnSpc>
+              <a:spcBef>
+                <a:spcPts val="0"/>
+              </a:spcBef>
+              <a:spcAft>
+                <a:spcPts val="0"/>
+              </a:spcAft>
+              <a:defRPr sz="2000" b="0">
+                <a:solidFill>
+                  <a:srgbClr val="24384A"/>
+                </a:solidFill>
+                <a:latin typeface="Lato"/>
+              </a:defRPr>
+            </a:pPr>
+            <a:r>
+              <a:rPr>
+                <a:ea typeface="Microsoft JhengHei"/>
+              </a:rPr>
+              <a:t>Questions to investigate</a:t>
+            </a:r>
+          </a:p>
+        </p:txBody>
+      </p:sp>
+      <p:sp>
+        <p:nvSpPr>
+          <p:cNvPr id="11" name="Rectangle 10"/>
+          <p:cNvSpPr/>
+          <p:nvPr/>
+        </p:nvSpPr>
+        <p:spPr>
+          <a:xfrm>
+            <a:off x="8334375" y="3048000"/>
+            <a:ext cx="3333750" cy="1666875"/>
+          </a:xfrm>
+          <a:prstGeom prst="rect">
+            <a:avLst/>
+          </a:prstGeom>
+          <a:solidFill>
+            <a:srgbClr val="E8F4F1"/>
+          </a:solidFill>
+          <a:ln w="12700">
+            <a:solidFill>
+              <a:srgbClr val="146C68"/>
+            </a:solidFill>
+          </a:ln>
+        </p:spPr>
+        <p:style>
+          <a:lnRef idx="1">
+            <a:schemeClr val="accent1"/>
+          </a:lnRef>
+          <a:fillRef idx="3">
+            <a:schemeClr val="accent1"/>
+          </a:fillRef>
+          <a:effectRef idx="2">
+            <a:schemeClr val="accent1"/>
+          </a:effectRef>
+          <a:fontRef idx="minor">
+            <a:schemeClr val="lt1"/>
+          </a:fontRef>
+        </p:style>
+        <p:txBody>
+          <a:bodyPr rtlCol="0" anchor="ctr"/>
+          <a:lstStyle/>
+          <a:p>
+            <a:pPr algn="ctr"/>
+          </a:p>
+        </p:txBody>
+      </p:sp>
+      <p:sp>
+        <p:nvSpPr>
           <p:cNvPr id="12" name="TextBox 11"/>
+          <p:cNvSpPr txBox="1"/>
+          <p:nvPr/>
+        </p:nvSpPr>
+        <p:spPr>
+          <a:xfrm>
+            <a:off x="8505825" y="3219450"/>
+            <a:ext cx="2990850" cy="476250"/>
+          </a:xfrm>
+          <a:prstGeom prst="rect">
+            <a:avLst/>
+          </a:prstGeom>
+          <a:noFill/>
+        </p:spPr>
+        <p:txBody>
+          <a:bodyPr wrap="square" lIns="0" rIns="0" tIns="0" bIns="0">
+            <a:spAutoFit/>
+          </a:bodyPr>
+          <a:lstStyle/>
+          <a:p>
+            <a:pPr>
+              <a:lnSpc>
+                <a:spcPct val="118000"/>
+              </a:lnSpc>
+              <a:spcBef>
+                <a:spcPts val="0"/>
+              </a:spcBef>
+              <a:spcAft>
+                <a:spcPts val="0"/>
+              </a:spcAft>
+              <a:defRPr sz="2200" b="1">
+                <a:solidFill>
+                  <a:srgbClr val="146C68"/>
+                </a:solidFill>
+                <a:latin typeface="Lato"/>
+              </a:defRPr>
+            </a:pPr>
+            <a:r>
+              <a:rPr>
+                <a:ea typeface="Microsoft JhengHei"/>
+              </a:rPr>
+              <a:t>Inspect and decide</a:t>
+            </a:r>
+          </a:p>
+        </p:txBody>
+      </p:sp>
+      <p:sp>
+        <p:nvSpPr>
+          <p:cNvPr id="13" name="TextBox 12"/>
+          <p:cNvSpPr txBox="1"/>
+          <p:nvPr/>
+        </p:nvSpPr>
+        <p:spPr>
+          <a:xfrm>
+            <a:off x="8505825" y="3857625"/>
+            <a:ext cx="2990850" cy="742950"/>
+          </a:xfrm>
+          <a:prstGeom prst="rect">
+            <a:avLst/>
+          </a:prstGeom>
+          <a:noFill/>
+        </p:spPr>
+        <p:txBody>
+          <a:bodyPr wrap="square" lIns="0" rIns="0" tIns="0" bIns="0">
+            <a:spAutoFit/>
+          </a:bodyPr>
+          <a:lstStyle/>
+          <a:p>
+            <a:pPr>
+              <a:lnSpc>
+                <a:spcPct val="118000"/>
+              </a:lnSpc>
+              <a:spcBef>
+                <a:spcPts val="0"/>
+              </a:spcBef>
+              <a:spcAft>
+                <a:spcPts val="0"/>
+              </a:spcAft>
+              <a:defRPr sz="2000" b="0">
+                <a:solidFill>
+                  <a:srgbClr val="24384A"/>
+                </a:solidFill>
+                <a:latin typeface="Lato"/>
+              </a:defRPr>
+            </a:pPr>
+            <a:r>
+              <a:rPr>
+                <a:ea typeface="Microsoft JhengHei"/>
+              </a:rPr>
+              <a:t>Read the cited sources</a:t>
+            </a:r>
+          </a:p>
+          <a:p>
+            <a:pPr>
+              <a:lnSpc>
+                <a:spcPct val="118000"/>
+              </a:lnSpc>
+              <a:spcBef>
+                <a:spcPts val="0"/>
+              </a:spcBef>
+              <a:spcAft>
+                <a:spcPts val="0"/>
+              </a:spcAft>
+              <a:defRPr sz="2000" b="0">
+                <a:solidFill>
+                  <a:srgbClr val="24384A"/>
+                </a:solidFill>
+                <a:latin typeface="Lato"/>
+              </a:defRPr>
+            </a:pPr>
+            <a:r>
+              <a:rPr>
+                <a:ea typeface="Microsoft JhengHei"/>
+              </a:rPr>
+              <a:t>Choose what to pursue</a:t>
+            </a:r>
+          </a:p>
+        </p:txBody>
+      </p:sp>
+      <p:cxnSp>
+        <p:nvCxnSpPr>
+          <p:cNvPr id="14" name="Connector 13"/>
+          <p:cNvCxnSpPr/>
+          <p:nvPr/>
+        </p:nvCxnSpPr>
+        <p:spPr>
+          <a:xfrm>
+            <a:off x="3933824" y="3857625"/>
+            <a:ext cx="409575" cy="0"/>
+          </a:xfrm>
+          <a:prstGeom prst="line">
+            <a:avLst/>
+          </a:prstGeom>
+          <a:ln w="19050">
+            <a:solidFill>
+              <a:srgbClr val="526778"/>
+            </a:solidFill>
+            <a:tailEnd type="triangle"/>
+          </a:ln>
+        </p:spPr>
+        <p:style>
+          <a:lnRef idx="2">
+            <a:schemeClr val="accent1"/>
+          </a:lnRef>
+          <a:fillRef idx="0">
+            <a:schemeClr val="accent1"/>
+          </a:fillRef>
+          <a:effectRef idx="1">
+            <a:schemeClr val="accent1"/>
+          </a:effectRef>
+          <a:fontRef idx="minor">
+            <a:schemeClr val="tx1"/>
+          </a:fontRef>
+        </p:style>
+      </p:cxnSp>
+      <p:cxnSp>
+        <p:nvCxnSpPr>
+          <p:cNvPr id="15" name="Connector 14"/>
+          <p:cNvCxnSpPr/>
+          <p:nvPr/>
+        </p:nvCxnSpPr>
+        <p:spPr>
+          <a:xfrm>
+            <a:off x="7839074" y="3857625"/>
+            <a:ext cx="409575" cy="0"/>
+          </a:xfrm>
+          <a:prstGeom prst="line">
+            <a:avLst/>
+          </a:prstGeom>
+          <a:ln w="19050">
+            <a:solidFill>
+              <a:srgbClr val="526778"/>
+            </a:solidFill>
+            <a:tailEnd type="triangle"/>
+          </a:ln>
+        </p:spPr>
+        <p:style>
+          <a:lnRef idx="2">
+            <a:schemeClr val="accent1"/>
+          </a:lnRef>
+          <a:fillRef idx="0">
+            <a:schemeClr val="accent1"/>
+          </a:fillRef>
+          <a:effectRef idx="1">
+            <a:schemeClr val="accent1"/>
+          </a:effectRef>
+          <a:fontRef idx="minor">
+            <a:schemeClr val="tx1"/>
+          </a:fontRef>
+        </p:style>
+      </p:cxnSp>
+      <p:sp>
+        <p:nvSpPr>
+          <p:cNvPr id="16" name="TextBox 15"/>
+          <p:cNvSpPr txBox="1"/>
+          <p:nvPr/>
+        </p:nvSpPr>
+        <p:spPr>
+          <a:xfrm>
+            <a:off x="523874" y="5105400"/>
+            <a:ext cx="2286000" cy="447675"/>
+          </a:xfrm>
+          <a:prstGeom prst="rect">
+            <a:avLst/>
+          </a:prstGeom>
+          <a:noFill/>
+        </p:spPr>
+        <p:txBody>
+          <a:bodyPr wrap="square" lIns="0" rIns="0" tIns="0" bIns="0">
+            <a:spAutoFit/>
+          </a:bodyPr>
+          <a:lstStyle/>
+          <a:p>
+            <a:pPr>
+              <a:lnSpc>
+                <a:spcPct val="118000"/>
+              </a:lnSpc>
+              <a:spcBef>
+                <a:spcPts val="0"/>
+              </a:spcBef>
+              <a:spcAft>
+                <a:spcPts val="0"/>
+              </a:spcAft>
+              <a:defRPr sz="2500" b="1">
+                <a:solidFill>
+                  <a:srgbClr val="146C68"/>
+                </a:solidFill>
+                <a:latin typeface="Lato"/>
+              </a:defRPr>
+            </a:pPr>
+            <a:r>
+              <a:rPr>
+                <a:ea typeface="Microsoft JhengHei"/>
+              </a:rPr>
+              <a:t>Graph</a:t>
+            </a:r>
+          </a:p>
+        </p:txBody>
+      </p:sp>
+      <p:sp>
+        <p:nvSpPr>
+          <p:cNvPr id="17" name="TextBox 16"/>
+          <p:cNvSpPr txBox="1"/>
+          <p:nvPr/>
+        </p:nvSpPr>
+        <p:spPr>
+          <a:xfrm>
+            <a:off x="2762250" y="5105400"/>
+            <a:ext cx="8858250" cy="762000"/>
+          </a:xfrm>
+          <a:prstGeom prst="rect">
+            <a:avLst/>
+          </a:prstGeom>
+          <a:noFill/>
+        </p:spPr>
+        <p:txBody>
+          <a:bodyPr wrap="square" lIns="0" rIns="0" tIns="0" bIns="0">
+            <a:spAutoFit/>
+          </a:bodyPr>
+          <a:lstStyle/>
+          <a:p>
+            <a:pPr>
+              <a:lnSpc>
+                <a:spcPct val="118000"/>
+              </a:lnSpc>
+              <a:spcBef>
+                <a:spcPts val="0"/>
+              </a:spcBef>
+              <a:spcAft>
+                <a:spcPts val="0"/>
+              </a:spcAft>
+              <a:defRPr sz="2300" b="0">
+                <a:solidFill>
+                  <a:srgbClr val="24384A"/>
+                </a:solidFill>
+                <a:latin typeface="Lato"/>
+              </a:defRPr>
+            </a:pPr>
+            <a:r>
+              <a:rPr>
+                <a:ea typeface="Microsoft JhengHei"/>
+              </a:rPr>
+              <a:t>Keeps proposals linked to passages, checks and researcher decisions.</a:t>
+            </a:r>
+          </a:p>
+        </p:txBody>
+      </p:sp>
+      <p:sp>
+        <p:nvSpPr>
+          <p:cNvPr id="18" name="TextBox 17"/>
+          <p:cNvSpPr txBox="1"/>
+          <p:nvPr/>
+        </p:nvSpPr>
+        <p:spPr>
+          <a:xfrm>
+            <a:off x="523874" y="5962650"/>
+            <a:ext cx="11049000" cy="390525"/>
+          </a:xfrm>
+          <a:prstGeom prst="rect">
+            <a:avLst/>
+          </a:prstGeom>
+          <a:noFill/>
+        </p:spPr>
+        <p:txBody>
+          <a:bodyPr wrap="square" lIns="0" rIns="0" tIns="0" bIns="0">
+            <a:spAutoFit/>
+          </a:bodyPr>
+          <a:lstStyle/>
+          <a:p>
+            <a:pPr>
+              <a:lnSpc>
+                <a:spcPct val="118000"/>
+              </a:lnSpc>
+              <a:spcBef>
+                <a:spcPts val="0"/>
+              </a:spcBef>
+              <a:spcAft>
+                <a:spcPts val="0"/>
+              </a:spcAft>
+              <a:defRPr sz="2200" b="0">
+                <a:solidFill>
+                  <a:srgbClr val="526778"/>
+                </a:solidFill>
+                <a:latin typeface="Lato"/>
+              </a:defRPr>
+            </a:pPr>
+            <a:r>
+              <a:rPr>
+                <a:ea typeface="Microsoft JhengHei"/>
+              </a:rPr>
+              <a:t>A citation that resolves can still support a weak interpretation.</a:t>
+            </a:r>
+          </a:p>
+        </p:txBody>
+      </p:sp>
+      <p:sp>
+        <p:nvSpPr>
+          <p:cNvPr id="19" name="Rectangle 18"/>
+          <p:cNvSpPr/>
+          <p:nvPr/>
+        </p:nvSpPr>
+        <p:spPr>
+          <a:xfrm>
+            <a:off x="11334750" y="6429375"/>
+            <a:ext cx="647700" cy="333375"/>
+          </a:xfrm>
+          <a:prstGeom prst="rect">
+            <a:avLst/>
+          </a:prstGeom>
+          <a:solidFill>
+            <a:srgbClr val="24384A"/>
+          </a:solidFill>
+          <a:ln w="12700">
+            <a:solidFill>
+              <a:srgbClr val="24384A"/>
+            </a:solidFill>
+          </a:ln>
+        </p:spPr>
+        <p:style>
+          <a:lnRef idx="1">
+            <a:schemeClr val="accent1"/>
+          </a:lnRef>
+          <a:fillRef idx="3">
+            <a:schemeClr val="accent1"/>
+          </a:fillRef>
+          <a:effectRef idx="2">
+            <a:schemeClr val="accent1"/>
+          </a:effectRef>
+          <a:fontRef idx="minor">
+            <a:schemeClr val="lt1"/>
+          </a:fontRef>
+        </p:style>
+        <p:txBody>
+          <a:bodyPr rtlCol="0" anchor="ctr"/>
+          <a:lstStyle/>
+          <a:p>
+            <a:pPr algn="ctr"/>
+          </a:p>
+        </p:txBody>
+      </p:sp>
+      <p:sp>
+        <p:nvSpPr>
+          <p:cNvPr id="20" name="TextBox 19"/>
           <p:cNvSpPr txBox="1"/>
           <p:nvPr/>
         </p:nvSpPr>

</xml_diff>

<commit_message>
Explain evidence graph provenance benefits and future link prediction
</commit_message>
<xml_diff>
--- a/docs/presentation/cohort-pnc-2026.pptx
+++ b/docs/presentation/cohort-pnc-2026.pptx
@@ -1955,6 +1955,41 @@
         <p:txBody>
           <a:bodyPr/>
           <a:lstStyle/>
+          <a:p>
+            <a:r>
+              <a:t>SAY: The graph helps us trace proposals back to sources, inspect recorded relationships between sources, and retain the history of checks and decisions. A possible next step is edge prediction: suggesting a relationship worth investigating. We have not implemented or evaluated that capability.</a:t>
+            </a:r>
+          </a:p>
+          <a:p/>
+          <a:p>
+            <a:r>
+              <a:t>TERMINOLOGY: Cohort has typed nodes, typed edges and record metadata. These are familiar graph-data techniques. The project deliberately calls this an evidence graph because translator and historical assertions remain contested. This does not mean that all knowledge graphs must contain only certain facts; it explains the terminology and epistemic contract of this application. See docs/design.md principles 1–2 and section 10.</a:t>
+            </a:r>
+          </a:p>
+          <a:p/>
+          <a:p>
+            <a:r>
+              <a:t>DEPENDENCIES: Recorded quotes, parallel_of and descends_from relationships help expose related material. A graph cannot display a dependency that nobody has recorded, and an independence flag is not proof that sources are historically independent. Repeated checks are not independent witnesses.</a:t>
+            </a:r>
+          </a:p>
+          <a:p/>
+          <a:p>
+            <a:r>
+              <a:t>EDGE PREDICTION: In graph research, link prediction scores possible missing relationships between nodes. A future Cohort feature could propose a candidate quotation or textual parallel, retrieve the relevant passages and send it for review. A predicted link would be a proposal, not historical evidence by itself. Current semantic-neighbour retrieval compares passage vectors; it is not a trained graph link-prediction model. The source-grounded edge-proposal workflow would also need implementation and evaluation.</a:t>
+            </a:r>
+          </a:p>
+          <a:p/>
+          <a:p>
+            <a:r>
+              <a:t>BACKGROUND READING: Hogan et al., Knowledge Graphs (2021), https://arxiv.org/abs/2003.02320; Daza et al., Inductive Entity Representations from Text via Link Prediction (2021), https://arxiv.org/abs/2010.03496.</a:t>
+            </a:r>
+          </a:p>
+          <a:p/>
+          <a:p>
+            <a:r>
+              <a:t>EXISTING CHECKS AND DECISIONS</a:t>
+            </a:r>
+          </a:p>
           <a:p>
             <a:r>
               <a:t>SAY: Finding a quotation at its source is one check. Whether it supports the interpretation requires reading. Accepting a passage does not accept every connected proposal.</a:t>
@@ -13903,7 +13938,7 @@
         <p:spPr>
           <a:xfrm>
             <a:off x="495299" y="742950"/>
-            <a:ext cx="11144250" cy="1047749"/>
+            <a:ext cx="11144250" cy="952500"/>
           </a:xfrm>
           <a:prstGeom prst="rect">
             <a:avLst/>
@@ -13937,7 +13972,7 @@
               <a:rPr>
                 <a:ea typeface="Microsoft JhengHei"/>
               </a:rPr>
-              <a:t>Checks and researcher decisions</a:t>
+              <a:t>Why use an evidence graph?</a:t>
             </a:r>
           </a:p>
         </p:txBody>
@@ -13950,31 +13985,31 @@
         </p:nvSpPr>
         <p:spPr>
           <a:xfrm>
-            <a:off x="714375" y="2390775"/>
-            <a:ext cx="3000375" cy="476250"/>
-          </a:xfrm>
-          <a:prstGeom prst="rect">
-            <a:avLst/>
-          </a:prstGeom>
-          <a:noFill/>
-        </p:spPr>
-        <p:txBody>
-          <a:bodyPr wrap="square" lIns="0" rIns="0" tIns="0" bIns="0">
-            <a:spAutoFit/>
-          </a:bodyPr>
-          <a:lstStyle/>
-          <a:p>
-            <a:pPr>
-              <a:lnSpc>
-                <a:spcPct val="118000"/>
-              </a:lnSpc>
-              <a:spcBef>
-                <a:spcPts val="0"/>
-              </a:spcBef>
-              <a:spcAft>
-                <a:spcPts val="0"/>
-              </a:spcAft>
-              <a:defRPr sz="2300" b="1">
+            <a:off x="523874" y="1924049"/>
+            <a:ext cx="3190875" cy="752475"/>
+          </a:xfrm>
+          <a:prstGeom prst="rect">
+            <a:avLst/>
+          </a:prstGeom>
+          <a:noFill/>
+        </p:spPr>
+        <p:txBody>
+          <a:bodyPr wrap="square" lIns="0" rIns="0" tIns="0" bIns="0">
+            <a:spAutoFit/>
+          </a:bodyPr>
+          <a:lstStyle/>
+          <a:p>
+            <a:pPr>
+              <a:lnSpc>
+                <a:spcPct val="118000"/>
+              </a:lnSpc>
+              <a:spcBef>
+                <a:spcPts val="0"/>
+              </a:spcBef>
+              <a:spcAft>
+                <a:spcPts val="0"/>
+              </a:spcAft>
+              <a:defRPr sz="2500" b="1">
                 <a:solidFill>
                   <a:srgbClr val="146C68"/>
                 </a:solidFill>
@@ -13985,7 +14020,7 @@
               <a:rPr>
                 <a:ea typeface="Microsoft JhengHei"/>
               </a:rPr>
-              <a:t>Span verified</a:t>
+              <a:t>Trace a proposal</a:t>
             </a:r>
           </a:p>
         </p:txBody>
@@ -13998,31 +14033,31 @@
         </p:nvSpPr>
         <p:spPr>
           <a:xfrm>
-            <a:off x="714375" y="3000375"/>
-            <a:ext cx="3000375" cy="1333500"/>
-          </a:xfrm>
-          <a:prstGeom prst="rect">
-            <a:avLst/>
-          </a:prstGeom>
-          <a:noFill/>
-        </p:spPr>
-        <p:txBody>
-          <a:bodyPr wrap="square" lIns="0" rIns="0" tIns="0" bIns="0">
-            <a:spAutoFit/>
-          </a:bodyPr>
-          <a:lstStyle/>
-          <a:p>
-            <a:pPr>
-              <a:lnSpc>
-                <a:spcPct val="118000"/>
-              </a:lnSpc>
-              <a:spcBef>
-                <a:spcPts val="0"/>
-              </a:spcBef>
-              <a:spcAft>
-                <a:spcPts val="0"/>
-              </a:spcAft>
-              <a:defRPr sz="2100" b="0">
+            <a:off x="4095750" y="1924049"/>
+            <a:ext cx="7524749" cy="885825"/>
+          </a:xfrm>
+          <a:prstGeom prst="rect">
+            <a:avLst/>
+          </a:prstGeom>
+          <a:noFill/>
+        </p:spPr>
+        <p:txBody>
+          <a:bodyPr wrap="square" lIns="0" rIns="0" tIns="0" bIns="0">
+            <a:spAutoFit/>
+          </a:bodyPr>
+          <a:lstStyle/>
+          <a:p>
+            <a:pPr>
+              <a:lnSpc>
+                <a:spcPct val="118000"/>
+              </a:lnSpc>
+              <a:spcBef>
+                <a:spcPts val="0"/>
+              </a:spcBef>
+              <a:spcAft>
+                <a:spcPts val="0"/>
+              </a:spcAft>
+              <a:defRPr sz="2400" b="0">
                 <a:solidFill>
                   <a:srgbClr val="24384A"/>
                 </a:solidFill>
@@ -14033,21 +14068,92 @@
               <a:rPr>
                 <a:ea typeface="Microsoft JhengHei"/>
               </a:rPr>
-              <a:t>The quotation resolves</a:t>
-            </a:r>
-          </a:p>
-          <a:p>
-            <a:pPr>
-              <a:lnSpc>
-                <a:spcPct val="118000"/>
-              </a:lnSpc>
-              <a:spcBef>
-                <a:spcPts val="0"/>
-              </a:spcBef>
-              <a:spcAft>
-                <a:spcPts val="0"/>
-              </a:spcAft>
-              <a:defRPr sz="2100" b="0">
+              <a:t>Follow its citations to passages and source records.</a:t>
+            </a:r>
+          </a:p>
+        </p:txBody>
+      </p:sp>
+      <p:sp>
+        <p:nvSpPr>
+          <p:cNvPr id="6" name="TextBox 5"/>
+          <p:cNvSpPr txBox="1"/>
+          <p:nvPr/>
+        </p:nvSpPr>
+        <p:spPr>
+          <a:xfrm>
+            <a:off x="523874" y="2962275"/>
+            <a:ext cx="3190875" cy="752475"/>
+          </a:xfrm>
+          <a:prstGeom prst="rect">
+            <a:avLst/>
+          </a:prstGeom>
+          <a:noFill/>
+        </p:spPr>
+        <p:txBody>
+          <a:bodyPr wrap="square" lIns="0" rIns="0" tIns="0" bIns="0">
+            <a:spAutoFit/>
+          </a:bodyPr>
+          <a:lstStyle/>
+          <a:p>
+            <a:pPr>
+              <a:lnSpc>
+                <a:spcPct val="118000"/>
+              </a:lnSpc>
+              <a:spcBef>
+                <a:spcPts val="0"/>
+              </a:spcBef>
+              <a:spcAft>
+                <a:spcPts val="0"/>
+              </a:spcAft>
+              <a:defRPr sz="2500" b="1">
+                <a:solidFill>
+                  <a:srgbClr val="146C68"/>
+                </a:solidFill>
+                <a:latin typeface="Lato"/>
+              </a:defRPr>
+            </a:pPr>
+            <a:r>
+              <a:rPr>
+                <a:ea typeface="Microsoft JhengHei"/>
+              </a:rPr>
+              <a:t>Inspect dependencies</a:t>
+            </a:r>
+          </a:p>
+        </p:txBody>
+      </p:sp>
+      <p:sp>
+        <p:nvSpPr>
+          <p:cNvPr id="7" name="TextBox 6"/>
+          <p:cNvSpPr txBox="1"/>
+          <p:nvPr/>
+        </p:nvSpPr>
+        <p:spPr>
+          <a:xfrm>
+            <a:off x="4095750" y="2962275"/>
+            <a:ext cx="7524749" cy="885825"/>
+          </a:xfrm>
+          <a:prstGeom prst="rect">
+            <a:avLst/>
+          </a:prstGeom>
+          <a:noFill/>
+        </p:spPr>
+        <p:txBody>
+          <a:bodyPr wrap="square" lIns="0" rIns="0" tIns="0" bIns="0">
+            <a:spAutoFit/>
+          </a:bodyPr>
+          <a:lstStyle/>
+          <a:p>
+            <a:pPr>
+              <a:lnSpc>
+                <a:spcPct val="118000"/>
+              </a:lnSpc>
+              <a:spcBef>
+                <a:spcPts val="0"/>
+              </a:spcBef>
+              <a:spcAft>
+                <a:spcPts val="0"/>
+              </a:spcAft>
+              <a:defRPr sz="2400" b="0">
                 <a:solidFill>
                   <a:srgbClr val="24384A"/>
                 </a:solidFill>
@@ -14058,44 +14164,44 @@
               <a:rPr>
                 <a:ea typeface="Microsoft JhengHei"/>
               </a:rPr>
-              <a:t>at its source position.</a:t>
-            </a:r>
-          </a:p>
-        </p:txBody>
-      </p:sp>
-      <p:sp>
-        <p:nvSpPr>
-          <p:cNvPr id="6" name="TextBox 5"/>
-          <p:cNvSpPr txBox="1"/>
-          <p:nvPr/>
-        </p:nvSpPr>
-        <p:spPr>
-          <a:xfrm>
-            <a:off x="4572000" y="2390775"/>
-            <a:ext cx="3000375" cy="476250"/>
-          </a:xfrm>
-          <a:prstGeom prst="rect">
-            <a:avLst/>
-          </a:prstGeom>
-          <a:noFill/>
-        </p:spPr>
-        <p:txBody>
-          <a:bodyPr wrap="square" lIns="0" rIns="0" tIns="0" bIns="0">
-            <a:spAutoFit/>
-          </a:bodyPr>
-          <a:lstStyle/>
-          <a:p>
-            <a:pPr>
-              <a:lnSpc>
-                <a:spcPct val="118000"/>
-              </a:lnSpc>
-              <a:spcBef>
-                <a:spcPts val="0"/>
-              </a:spcBef>
-              <a:spcAft>
-                <a:spcPts val="0"/>
-              </a:spcAft>
-              <a:defRPr sz="2300" b="1">
+              <a:t>See recorded quotation, parallel and descent links.</a:t>
+            </a:r>
+          </a:p>
+        </p:txBody>
+      </p:sp>
+      <p:sp>
+        <p:nvSpPr>
+          <p:cNvPr id="8" name="TextBox 7"/>
+          <p:cNvSpPr txBox="1"/>
+          <p:nvPr/>
+        </p:nvSpPr>
+        <p:spPr>
+          <a:xfrm>
+            <a:off x="523874" y="4000500"/>
+            <a:ext cx="3190875" cy="752475"/>
+          </a:xfrm>
+          <a:prstGeom prst="rect">
+            <a:avLst/>
+          </a:prstGeom>
+          <a:noFill/>
+        </p:spPr>
+        <p:txBody>
+          <a:bodyPr wrap="square" lIns="0" rIns="0" tIns="0" bIns="0">
+            <a:spAutoFit/>
+          </a:bodyPr>
+          <a:lstStyle/>
+          <a:p>
+            <a:pPr>
+              <a:lnSpc>
+                <a:spcPct val="118000"/>
+              </a:lnSpc>
+              <a:spcBef>
+                <a:spcPts val="0"/>
+              </a:spcBef>
+              <a:spcAft>
+                <a:spcPts val="0"/>
+              </a:spcAft>
+              <a:defRPr sz="2500" b="1">
                 <a:solidFill>
                   <a:srgbClr val="146C68"/>
                 </a:solidFill>
@@ -14106,44 +14212,44 @@
               <a:rPr>
                 <a:ea typeface="Microsoft JhengHei"/>
               </a:rPr>
-              <a:t>Review recorded</a:t>
-            </a:r>
-          </a:p>
-        </p:txBody>
-      </p:sp>
-      <p:sp>
-        <p:nvSpPr>
-          <p:cNvPr id="7" name="TextBox 6"/>
-          <p:cNvSpPr txBox="1"/>
-          <p:nvPr/>
-        </p:nvSpPr>
-        <p:spPr>
-          <a:xfrm>
-            <a:off x="4572000" y="3000375"/>
-            <a:ext cx="3000375" cy="1333500"/>
-          </a:xfrm>
-          <a:prstGeom prst="rect">
-            <a:avLst/>
-          </a:prstGeom>
-          <a:noFill/>
-        </p:spPr>
-        <p:txBody>
-          <a:bodyPr wrap="square" lIns="0" rIns="0" tIns="0" bIns="0">
-            <a:spAutoFit/>
-          </a:bodyPr>
-          <a:lstStyle/>
-          <a:p>
-            <a:pPr>
-              <a:lnSpc>
-                <a:spcPct val="118000"/>
-              </a:lnSpc>
-              <a:spcBef>
-                <a:spcPts val="0"/>
-              </a:spcBef>
-              <a:spcAft>
-                <a:spcPts val="0"/>
-              </a:spcAft>
-              <a:defRPr sz="2100" b="0">
+              <a:t>Keep the history</a:t>
+            </a:r>
+          </a:p>
+        </p:txBody>
+      </p:sp>
+      <p:sp>
+        <p:nvSpPr>
+          <p:cNvPr id="9" name="TextBox 8"/>
+          <p:cNvSpPr txBox="1"/>
+          <p:nvPr/>
+        </p:nvSpPr>
+        <p:spPr>
+          <a:xfrm>
+            <a:off x="4095750" y="4000500"/>
+            <a:ext cx="7524749" cy="885825"/>
+          </a:xfrm>
+          <a:prstGeom prst="rect">
+            <a:avLst/>
+          </a:prstGeom>
+          <a:noFill/>
+        </p:spPr>
+        <p:txBody>
+          <a:bodyPr wrap="square" lIns="0" rIns="0" tIns="0" bIns="0">
+            <a:spAutoFit/>
+          </a:bodyPr>
+          <a:lstStyle/>
+          <a:p>
+            <a:pPr>
+              <a:lnSpc>
+                <a:spcPct val="118000"/>
+              </a:lnSpc>
+              <a:spcBef>
+                <a:spcPts val="0"/>
+              </a:spcBef>
+              <a:spcAft>
+                <a:spcPts val="0"/>
+              </a:spcAft>
+              <a:defRPr sz="2400" b="0">
                 <a:solidFill>
                   <a:srgbClr val="24384A"/>
                 </a:solidFill>
@@ -14154,21 +14260,92 @@
               <a:rPr>
                 <a:ea typeface="Microsoft JhengHei"/>
               </a:rPr>
-              <a:t>Inspect the reviewer’s</a:t>
-            </a:r>
-          </a:p>
-          <a:p>
-            <a:pPr>
-              <a:lnSpc>
-                <a:spcPct val="118000"/>
-              </a:lnSpc>
-              <a:spcBef>
-                <a:spcPts val="0"/>
-              </a:spcBef>
-              <a:spcAft>
-                <a:spcPts val="0"/>
-              </a:spcAft>
-              <a:defRPr sz="2100" b="0">
+              <a:t>Who proposed it, what was checked, what the researcher decided.</a:t>
+            </a:r>
+          </a:p>
+        </p:txBody>
+      </p:sp>
+      <p:sp>
+        <p:nvSpPr>
+          <p:cNvPr id="10" name="TextBox 9"/>
+          <p:cNvSpPr txBox="1"/>
+          <p:nvPr/>
+        </p:nvSpPr>
+        <p:spPr>
+          <a:xfrm>
+            <a:off x="523874" y="5276850"/>
+            <a:ext cx="11049000" cy="428625"/>
+          </a:xfrm>
+          <a:prstGeom prst="rect">
+            <a:avLst/>
+          </a:prstGeom>
+          <a:noFill/>
+        </p:spPr>
+        <p:txBody>
+          <a:bodyPr wrap="square" lIns="0" rIns="0" tIns="0" bIns="0">
+            <a:spAutoFit/>
+          </a:bodyPr>
+          <a:lstStyle/>
+          <a:p>
+            <a:pPr>
+              <a:lnSpc>
+                <a:spcPct val="118000"/>
+              </a:lnSpc>
+              <a:spcBef>
+                <a:spcPts val="0"/>
+              </a:spcBef>
+              <a:spcAft>
+                <a:spcPts val="0"/>
+              </a:spcAft>
+              <a:defRPr sz="2400" b="1">
+                <a:solidFill>
+                  <a:srgbClr val="65439A"/>
+                </a:solidFill>
+                <a:latin typeface="Lato"/>
+              </a:defRPr>
+            </a:pPr>
+            <a:r>
+              <a:rPr>
+                <a:ea typeface="Microsoft JhengHei"/>
+              </a:rPr>
+              <a:t>Future work: edge prediction</a:t>
+            </a:r>
+          </a:p>
+        </p:txBody>
+      </p:sp>
+      <p:sp>
+        <p:nvSpPr>
+          <p:cNvPr id="11" name="TextBox 10"/>
+          <p:cNvSpPr txBox="1"/>
+          <p:nvPr/>
+        </p:nvSpPr>
+        <p:spPr>
+          <a:xfrm>
+            <a:off x="523874" y="5810250"/>
+            <a:ext cx="11049000" cy="504825"/>
+          </a:xfrm>
+          <a:prstGeom prst="rect">
+            <a:avLst/>
+          </a:prstGeom>
+          <a:noFill/>
+        </p:spPr>
+        <p:txBody>
+          <a:bodyPr wrap="square" lIns="0" rIns="0" tIns="0" bIns="0">
+            <a:spAutoFit/>
+          </a:bodyPr>
+          <a:lstStyle/>
+          <a:p>
+            <a:pPr>
+              <a:lnSpc>
+                <a:spcPct val="118000"/>
+              </a:lnSpc>
+              <a:spcBef>
+                <a:spcPts val="0"/>
+              </a:spcBef>
+              <a:spcAft>
+                <a:spcPts val="0"/>
+              </a:spcAft>
+              <a:defRPr sz="2300" b="0">
                 <a:solidFill>
                   <a:srgbClr val="24384A"/>
                 </a:solidFill>
@@ -14179,224 +14356,7 @@
               <a:rPr>
                 <a:ea typeface="Microsoft JhengHei"/>
               </a:rPr>
-              <a:t>verdict and evidence.</a:t>
-            </a:r>
-          </a:p>
-        </p:txBody>
-      </p:sp>
-      <p:sp>
-        <p:nvSpPr>
-          <p:cNvPr id="8" name="TextBox 7"/>
-          <p:cNvSpPr txBox="1"/>
-          <p:nvPr/>
-        </p:nvSpPr>
-        <p:spPr>
-          <a:xfrm>
-            <a:off x="8429625" y="2390775"/>
-            <a:ext cx="3000375" cy="476250"/>
-          </a:xfrm>
-          <a:prstGeom prst="rect">
-            <a:avLst/>
-          </a:prstGeom>
-          <a:noFill/>
-        </p:spPr>
-        <p:txBody>
-          <a:bodyPr wrap="square" lIns="0" rIns="0" tIns="0" bIns="0">
-            <a:spAutoFit/>
-          </a:bodyPr>
-          <a:lstStyle/>
-          <a:p>
-            <a:pPr>
-              <a:lnSpc>
-                <a:spcPct val="118000"/>
-              </a:lnSpc>
-              <a:spcBef>
-                <a:spcPts val="0"/>
-              </a:spcBef>
-              <a:spcAft>
-                <a:spcPts val="0"/>
-              </a:spcAft>
-              <a:defRPr sz="2300" b="1">
-                <a:solidFill>
-                  <a:srgbClr val="146C68"/>
-                </a:solidFill>
-                <a:latin typeface="Lato"/>
-              </a:defRPr>
-            </a:pPr>
-            <a:r>
-              <a:rPr>
-                <a:ea typeface="Microsoft JhengHei"/>
-              </a:rPr>
-              <a:t>Researcher decides</a:t>
-            </a:r>
-          </a:p>
-        </p:txBody>
-      </p:sp>
-      <p:sp>
-        <p:nvSpPr>
-          <p:cNvPr id="9" name="TextBox 8"/>
-          <p:cNvSpPr txBox="1"/>
-          <p:nvPr/>
-        </p:nvSpPr>
-        <p:spPr>
-          <a:xfrm>
-            <a:off x="8429625" y="3000375"/>
-            <a:ext cx="3000375" cy="1333500"/>
-          </a:xfrm>
-          <a:prstGeom prst="rect">
-            <a:avLst/>
-          </a:prstGeom>
-          <a:noFill/>
-        </p:spPr>
-        <p:txBody>
-          <a:bodyPr wrap="square" lIns="0" rIns="0" tIns="0" bIns="0">
-            <a:spAutoFit/>
-          </a:bodyPr>
-          <a:lstStyle/>
-          <a:p>
-            <a:pPr>
-              <a:lnSpc>
-                <a:spcPct val="118000"/>
-              </a:lnSpc>
-              <a:spcBef>
-                <a:spcPts val="0"/>
-              </a:spcBef>
-              <a:spcAft>
-                <a:spcPts val="0"/>
-              </a:spcAft>
-              <a:defRPr sz="2100" b="0">
-                <a:solidFill>
-                  <a:srgbClr val="24384A"/>
-                </a:solidFill>
-                <a:latin typeface="Lato"/>
-              </a:defRPr>
-            </a:pPr>
-            <a:r>
-              <a:rPr>
-                <a:ea typeface="Microsoft JhengHei"/>
-              </a:rPr>
-              <a:t>Accept or reject an</a:t>
-            </a:r>
-          </a:p>
-          <a:p>
-            <a:pPr>
-              <a:lnSpc>
-                <a:spcPct val="118000"/>
-              </a:lnSpc>
-              <a:spcBef>
-                <a:spcPts val="0"/>
-              </a:spcBef>
-              <a:spcAft>
-                <a:spcPts val="0"/>
-              </a:spcAft>
-              <a:defRPr sz="2100" b="0">
-                <a:solidFill>
-                  <a:srgbClr val="24384A"/>
-                </a:solidFill>
-                <a:latin typeface="Lato"/>
-              </a:defRPr>
-            </a:pPr>
-            <a:r>
-              <a:rPr>
-                <a:ea typeface="Microsoft JhengHei"/>
-              </a:rPr>
-              <a:t>eligible record.</a:t>
-            </a:r>
-          </a:p>
-        </p:txBody>
-      </p:sp>
-      <p:sp>
-        <p:nvSpPr>
-          <p:cNvPr id="10" name="TextBox 9"/>
-          <p:cNvSpPr txBox="1"/>
-          <p:nvPr/>
-        </p:nvSpPr>
-        <p:spPr>
-          <a:xfrm>
-            <a:off x="523874" y="5038725"/>
-            <a:ext cx="11049000" cy="619125"/>
-          </a:xfrm>
-          <a:prstGeom prst="rect">
-            <a:avLst/>
-          </a:prstGeom>
-          <a:noFill/>
-        </p:spPr>
-        <p:txBody>
-          <a:bodyPr wrap="square" lIns="0" rIns="0" tIns="0" bIns="0">
-            <a:spAutoFit/>
-          </a:bodyPr>
-          <a:lstStyle/>
-          <a:p>
-            <a:pPr>
-              <a:lnSpc>
-                <a:spcPct val="118000"/>
-              </a:lnSpc>
-              <a:spcBef>
-                <a:spcPts val="0"/>
-              </a:spcBef>
-              <a:spcAft>
-                <a:spcPts val="0"/>
-              </a:spcAft>
-              <a:defRPr sz="3000" b="1">
-                <a:solidFill>
-                  <a:srgbClr val="146C68"/>
-                </a:solidFill>
-                <a:latin typeface="Lato"/>
-              </a:defRPr>
-            </a:pPr>
-            <a:r>
-              <a:rPr>
-                <a:ea typeface="Microsoft JhengHei"/>
-              </a:rPr>
-              <a:t>Accepted passage ≠ accepted interpretation</a:t>
-            </a:r>
-          </a:p>
-        </p:txBody>
-      </p:sp>
-      <p:sp>
-        <p:nvSpPr>
-          <p:cNvPr id="11" name="TextBox 10"/>
-          <p:cNvSpPr txBox="1"/>
-          <p:nvPr/>
-        </p:nvSpPr>
-        <p:spPr>
-          <a:xfrm>
-            <a:off x="523874" y="5772150"/>
-            <a:ext cx="11049000" cy="466724"/>
-          </a:xfrm>
-          <a:prstGeom prst="rect">
-            <a:avLst/>
-          </a:prstGeom>
-          <a:noFill/>
-        </p:spPr>
-        <p:txBody>
-          <a:bodyPr wrap="square" lIns="0" rIns="0" tIns="0" bIns="0">
-            <a:spAutoFit/>
-          </a:bodyPr>
-          <a:lstStyle/>
-          <a:p>
-            <a:pPr>
-              <a:lnSpc>
-                <a:spcPct val="118000"/>
-              </a:lnSpc>
-              <a:spcBef>
-                <a:spcPts val="0"/>
-              </a:spcBef>
-              <a:spcAft>
-                <a:spcPts val="0"/>
-              </a:spcAft>
-              <a:defRPr sz="2200" b="0">
-                <a:solidFill>
-                  <a:srgbClr val="24384A"/>
-                </a:solidFill>
-                <a:latin typeface="Lato"/>
-              </a:defRPr>
-            </a:pPr>
-            <a:r>
-              <a:rPr>
-                <a:ea typeface="Microsoft JhengHei"/>
-              </a:rPr>
-              <a:t>Decisions stay in the record. The source text is unchanged.</a:t>
+              <a:t>Suggest a quotation or parallel to investigate, with passages to check.</a:t>
             </a:r>
           </a:p>
         </p:txBody>

</xml_diff>

<commit_message>
Add diachronic speaking cues and document compact action inspection
</commit_message>
<xml_diff>
--- a/docs/presentation/cohort-pnc-2026.pptx
+++ b/docs/presentation/cohort-pnc-2026.pptx
@@ -1133,6 +1133,12 @@
           <a:lstStyle/>
           <a:p>
             <a:r>
+              <a:t>TIME CUE: Compare material from different periods. Ask whether shared wording reflects transmission, reuse or revision. Dates and the direction of borrowing need historical evidence.</a:t>
+            </a:r>
+          </a:p>
+          <a:p/>
+          <a:p>
+            <a:r>
               <a:t>SAY: T1694 is in the mixed early-material group. Removing it changes that group’s profile and the leader. The target and vocabulary stay fixed. The margin is the score gap divided by distinct matched strings; it is not a probability.</a:t>
             </a:r>
           </a:p>
@@ -1388,6 +1394,12 @@
           <a:lstStyle/>
           <a:p>
             <a:r>
+              <a:t>TIME CUE: Compare material from different periods. Ask whether shared wording reflects transmission, reuse or revision. Dates and the direction of borrowing need historical evidence.</a:t>
+            </a:r>
+          </a:p>
+          <a:p/>
+          <a:p>
+            <a:r>
               <a:t>SAY: The worker can pull material together, suggest explanations we might want to examine, and propose a next search. These are possibilities for research. We inspect the cited passages and recorded checks before deciding what to pursue.</a:t>
             </a:r>
           </a:p>
@@ -3112,6 +3124,12 @@
         <p:txBody>
           <a:bodyPr/>
           <a:lstStyle/>
+          <a:p>
+            <a:r>
+              <a:t>TIME CUE: Compare material from different periods. Ask whether shared wording reflects transmission, reuse or revision. Dates and the direction of borrowing need historical evidence.</a:t>
+            </a:r>
+          </a:p>
+          <a:p/>
           <a:p>
             <a:r>
               <a:t>SAY: These two Lotus windows are close in the embedding index, but their longest exact shared sequence is only three Chinese characters. Retrieval gives us a pair to read; alignment shows where wording matches.</a:t>
@@ -8428,7 +8446,7 @@
               <a:rPr>
                 <a:ea typeface="Microsoft JhengHei"/>
               </a:rPr>
-              <a:t>A recorded comparison · curated strings</a:t>
+              <a:t>Across time · earlier text and later commentary</a:t>
             </a:r>
           </a:p>
         </p:txBody>
@@ -10042,7 +10060,7 @@
               <a:rPr>
                 <a:ea typeface="Microsoft JhengHei"/>
               </a:rPr>
-              <a:t>Interpretation · agents and researcher</a:t>
+              <a:t>Interpretation · reuse, revision and transmission</a:t>
             </a:r>
           </a:p>
         </p:txBody>
@@ -20973,7 +20991,7 @@
               <a:rPr>
                 <a:ea typeface="Microsoft JhengHei"/>
               </a:rPr>
-              <a:t>Retrieval and alignment</a:t>
+              <a:t>Across time · two Lotus translations</a:t>
             </a:r>
           </a:p>
         </p:txBody>

</xml_diff>

<commit_message>
Explain the relevance of the retrieved Lotus translation
</commit_message>
<xml_diff>
--- a/docs/presentation/cohort-pnc-2026.pptx
+++ b/docs/presentation/cohort-pnc-2026.pptx
@@ -3126,91 +3126,28 @@
           <a:lstStyle/>
           <a:p>
             <a:r>
-              <a:t>TIME CUE: Compare material from different periods. Ask whether shared wording reflects transmission, reuse or revision. Dates and the direction of borrowing need historical evidence.</a:t>
+              <a:t>TIME CUE: Two translations from different periods.</a:t>
             </a:r>
           </a:p>
           <a:p/>
           <a:p>
             <a:r>
-              <a:t>SAY: These two Lotus windows are close in the embedding index, but their longest exact shared sequence is only three Chinese characters. Retrieval gives us a pair to read; alignment shows where wording matches.</a:t>
+              <a:t>SAY: We start with Dharmarakṣa’s Lotus translation. The retrieved passage comes from Kumārajīva’s translation of the same sūtra. That makes it a relevant candidate for comparing how the work was translated, even though these windows share little exact wording.</a:t>
             </a:r>
           </a:p>
           <a:p/>
           <a:p>
             <a:r>
-              <a:t>BACKGROUND</a:t>
-            </a:r>
-          </a:p>
-          <a:p>
-            <a:r>
-              <a:t>Historical orientation: An Shigao worked in the second century CE. Scholarship identifies T1694 as a later commentary, probably from the third century; do not treat the date as inferred by Cohort. Its title repeats 陰持入經 and adds 註, commentary. This is why shared wording may reflect transmission over time rather than the same translator.</a:t>
+              <a:t>The measured source window is T0263-rest at position 4000; its nearest indexed window is T0262-exDevadatta at position 2800. Cosine similarity is 0.865 and the longest shared Chinese-character sequence is three characters. These values come from method-examples.json. The score ranks a candidate; it does not prove that the windows are exact counterparts. This presentation has not established a specialist passage-by-passage correspondence for the pair.</a:t>
             </a:r>
           </a:p>
           <a:p/>
           <a:p>
             <a:r>
-              <a:t>Explain the titles. T0603 is the Yin chi ru jing, associated with An Shigao. T1694 is its commentary; this relationship is known from scholarship. The tool locates shared runs, not the historical direction of borrowing.</a:t>
+              <a:t>T0263-rest is a catalogue remainder of Dharmarakṣa’s Lotus translation. T0262-exDevadatta is Kumārajīva’s translation with the separately catalogued Devadatta chapter excluded. CBETA links open the complete online work; local character offsets do not directly map to its pages.</a:t>
             </a:r>
           </a:p>
           <a:p/>
-          <a:p>
-            <a:r>
-              <a:t>These are tools available to agents; they are not separate top-level tabs.</a:t>
-            </a:r>
-          </a:p>
-          <a:p/>
-          <a:p>
-            <a:r>
-              <a:t>**Semantic neighbours** searches an embedding index. An embedding is a numerical representation used to retrieve passages with similar content. It supplies candidates to inspect. It does not establish who translated a passage. A nearest neighbour is the closest among the candidates searched; that alone does not make it a useful match.</a:t>
-            </a:r>
-          </a:p>
-          <a:p/>
-          <a:p>
-            <a:r>
-              <a:t>**Align passages** compares two selected texts for exact shared Chinese-character sequences and returns matching runs with source positions. Normalisation removes material such as punctuation from that comparison. Shared wording can suggest reuse, a common source or a recurring formula. Its direction and historical explanation require further evidence.</a:t>
-            </a:r>
-          </a:p>
-          <a:p/>
-          <a:p>
-            <a:r>
-              <a:t>T0603 is the *Yin chi ru jing* 陰持入經, traditionally associated with **An Shigao 安世高**. T1694 is the *Yin chi ru jing zhu* 陰持入經註, a commentary on it. The character 註 in the title means commentary, and the relationship is identified in scholarship. Cohort did not discover the genre from a similarity score. See the scholarly references at the end of this guide.</a:t>
-            </a:r>
-          </a:p>
-          <a:p/>
-          <a:p>
-            <a:r>
-              <a:t>In a saved run, show the action that retrieved candidates and the action that compared T0603 with T1694. Explain the tool inputs before the result. If the worker searched a short string taken from an earlier alignment, say that it reused a retrieved string. Do not describe a previously observed match as an independent prediction.</a:t>
-            </a:r>
-          </a:p>
-          <a:p/>
-          <a:p>
-            <a:r>
-              <a:t>The tools for comparing edition apparatus require the appropriate XML source configuration. The current plain-text setup supports the exact-overlap example; do not present it as a full textual-variant collation or a reconstruction of a text’s genealogy.</a:t>
-            </a:r>
-          </a:p>
-          <a:p/>
-          <a:p>
-            <a:r>
-              <a:t>SAY: The methods give us different things: candidate passages, vocabulary rankings and a way to test exclusions.</a:t>
-            </a:r>
-          </a:p>
-          <a:p/>
-          <a:p>
-            <a:r>
-              <a:t>NEXT: Explain the limitations.</a:t>
-            </a:r>
-          </a:p>
-          <a:p/>
-          <a:p>
-            <a:r>
-              <a:t>BACKGROUND</a:t>
-            </a:r>
-          </a:p>
-          <a:p>
-            <a:r>
-              <a:t>The first count concerns T0263-rest and T0262-exDevadatta, not every passage in complete editions. Nearest means first under vector similarity among indexed other works. This is an illustrative case selected after inspecting outputs, not a retrieval accuracy benchmark. Vocabulary excludes the target’s entire Taishō work, but other dependence and genre effects remain. Reverse control: T0262-exDevadatta ranks with Dharmakṣema under both vocabularies, not its catalogue label Kumārajīva. Mention that failure verbally: agreement for one example does not validate attribution. Measurements: scripts/check_method_examples.py; docs/presentation/method-examples.json.</a:t>
-            </a:r>
-          </a:p>
         </p:txBody>
       </p:sp>
       <p:sp>
@@ -20085,7 +20022,7 @@
               <a:rPr>
                 <a:ea typeface="Microsoft JhengHei"/>
               </a:rPr>
-              <a:t>Example: related content, little shared wording</a:t>
+              <a:t>Example: finding another Lotus translation</a:t>
             </a:r>
           </a:p>
         </p:txBody>
@@ -20473,7 +20410,7 @@
         <p:spPr>
           <a:xfrm>
             <a:off x="742950" y="5248275"/>
-            <a:ext cx="10620375" cy="476250"/>
+            <a:ext cx="10620375" cy="857250"/>
           </a:xfrm>
           <a:prstGeom prst="rect">
             <a:avLst/>
@@ -20496,7 +20433,7 @@
               <a:spcAft>
                 <a:spcPts val="0"/>
               </a:spcAft>
-              <a:defRPr sz="2200" b="0">
+              <a:defRPr sz="2300" b="0">
                 <a:solidFill>
                   <a:srgbClr val="24384A"/>
                 </a:solidFill>
@@ -20507,7 +20444,32 @@
               <a:rPr>
                 <a:ea typeface="Microsoft JhengHei"/>
               </a:rPr>
-              <a:t>Shared wording is checked separately, with positions in both sources.</a:t>
+              <a:t>The result is from another translation of the same sūtra.</a:t>
+            </a:r>
+          </a:p>
+          <a:p>
+            <a:pPr>
+              <a:lnSpc>
+                <a:spcPct val="118000"/>
+              </a:lnSpc>
+              <a:spcBef>
+                <a:spcPts val="0"/>
+              </a:spcBef>
+              <a:spcAft>
+                <a:spcPts val="0"/>
+              </a:spcAft>
+              <a:defRPr sz="2300" b="0">
+                <a:solidFill>
+                  <a:srgbClr val="24384A"/>
+                </a:solidFill>
+                <a:latin typeface="Lato"/>
+              </a:defRPr>
+            </a:pPr>
+            <a:r>
+              <a:rPr>
+                <a:ea typeface="Microsoft JhengHei"/>
+              </a:rPr>
+              <a:t>Read the passages to judge how closely they correspond.</a:t>
             </a:r>
           </a:p>
         </p:txBody>

</xml_diff>